<commit_message>
Slim repo: keep only slides and code on GitHub
</commit_message>
<xml_diff>
--- a/CSDS234_Qianyi_slides.pptx
+++ b/CSDS234_Qianyi_slides.pptx
@@ -1708,7 +1708,7 @@
                 <a:ea typeface="Calibri" pitchFamily="34" charset="-122"/>
                 <a:cs typeface="Calibri" pitchFamily="34" charset="-120"/>
               </a:rPr>
-              <a:t>Solo  ·  Prof. Yinghui Wu  ·  Case Western Reserve University</a:t>
+              <a:t>Case Western Reserve University</a:t>
             </a:r>
             <a:endParaRPr lang="en-US" sz="1600" dirty="0"/>
           </a:p>
@@ -2972,7 +2972,7 @@
         </p:nvSpPr>
         <p:spPr>
           <a:xfrm>
-            <a:off x="502920" y="1417320"/>
+            <a:off x="502920" y="1567094"/>
             <a:ext cx="5029200" cy="640080"/>
           </a:xfrm>
           <a:prstGeom prst="rect">

</xml_diff>